<commit_message>
Add Summary chapter slides (3 new slides: algorithms recap, results table, conclusions) + summary_chapter.md
</commit_message>
<xml_diff>
--- a/member4_visualization_report/tsp_bb_presentation.pptx
+++ b/member4_visualization_report/tsp_bb_presentation.pptx
@@ -17,6 +17,9 @@
     <p:sldId id="265" r:id="rId16"/>
     <p:sldId id="266" r:id="rId17"/>
     <p:sldId id="267" r:id="rId18"/>
+    <p:sldId id="268" r:id="rId19"/>
+    <p:sldId id="269" r:id="rId20"/>
+    <p:sldId id="270" r:id="rId21"/>
   </p:sldIdLst>
   <p:sldSz cx="12191695" cy="6858000" type="screen4x3"/>
   <p:notesSz cx="6858000" cy="9144000"/>
@@ -3268,7 +3271,7 @@
               </a:defRPr>
             </a:pPr>
             <a:r>
-              <a:t>Key Findings</a:t>
+              <a:t>Summary: Three Algorithms Compared</a:t>
             </a:r>
           </a:p>
         </p:txBody>
@@ -3306,7 +3309,7 @@
               </a:defRPr>
             </a:pPr>
             <a:r>
-              <a:t>B&amp;B finds provably optimal solutions (same as brute force) for all tested instances.</a:t>
+              <a:t>Brute Force — Exact baseline. Enumerates all (n-1)!/2 permutations. Guarantees optimality but O(n!). Impractical beyond n=10.</a:t>
             </a:r>
           </a:p>
           <a:p>
@@ -3321,7 +3324,7 @@
               </a:defRPr>
             </a:pPr>
             <a:r>
-              <a:t>At n=10, B&amp;B prunes 98.7% of the search space — visiting only 1.3% of all possible nodes.</a:t>
+              <a:t>Branch &amp; Bound — Exact with pruning. DFS + lower bound evaluation. Cuts branches when LB &gt;= best_cost. Optimal, far more efficient.</a:t>
             </a:r>
           </a:p>
           <a:p>
@@ -3336,7 +3339,7 @@
               </a:defRPr>
             </a:pPr>
             <a:r>
-              <a:t>B&amp;B is ~2.2× faster than brute force at n=9; gap widens with larger n.</a:t>
+              <a:t>Nearest Neighbor — Greedy heuristic. Always picks the closest unvisited city. O(n²) speed but 2–10% above optimal on average.</a:t>
             </a:r>
           </a:p>
           <a:p>
@@ -3351,22 +3354,7 @@
               </a:defRPr>
             </a:pPr>
             <a:r>
-              <a:t>Nearest Neighbor runs in near-zero time but solutions are 2-10% above optimal.</a:t>
-            </a:r>
-          </a:p>
-          <a:p>
-            <a:pPr>
-              <a:spcAft>
-                <a:spcPts val="1200"/>
-              </a:spcAft>
-              <a:defRPr sz="2200">
-                <a:solidFill>
-                  <a:srgbClr val="FFFFFF"/>
-                </a:solidFill>
-              </a:defRPr>
-            </a:pPr>
-            <a:r>
-              <a:t>B&amp;B is practical for n ≤ 14; beyond that, heuristics are needed.</a:t>
+              <a:t>Takeaway: B&amp;B strikes the best balance between correctness and efficiency for exact TSP solving at small to medium scale.</a:t>
             </a:r>
           </a:p>
         </p:txBody>
@@ -3427,7 +3415,833 @@
               </a:defRPr>
             </a:pPr>
             <a:r>
-              <a:t>Conclusion &amp; Future Work</a:t>
+              <a:t>Summary: Key Results</a:t>
+            </a:r>
+          </a:p>
+        </p:txBody>
+      </p:sp>
+      <p:graphicFrame>
+        <p:nvGraphicFramePr>
+          <p:cNvPr id="3" name="Table 2"/>
+          <p:cNvGraphicFramePr>
+            <a:graphicFrameLocks noGrp="1"/>
+          </p:cNvGraphicFramePr>
+          <p:nvPr/>
+        </p:nvGraphicFramePr>
+        <p:xfrm>
+          <a:off x="731520" y="1645920"/>
+          <a:ext cx="10515600" cy="3200400"/>
+        </p:xfrm>
+        <a:graphic>
+          <a:graphicData uri="http://schemas.openxmlformats.org/drawingml/2006/table">
+            <a:tbl>
+              <a:tblPr firstRow="1" bandRow="1">
+                <a:tableStyleId>{5C22544A-7EE6-4342-B048-85BDC9FD1C3A}</a:tableStyleId>
+              </a:tblPr>
+              <a:tblGrid>
+                <a:gridCol w="1752600"/>
+                <a:gridCol w="1752600"/>
+                <a:gridCol w="1752600"/>
+                <a:gridCol w="1752600"/>
+                <a:gridCol w="1752600"/>
+                <a:gridCol w="1752600"/>
+              </a:tblGrid>
+              <a:tr h="640080">
+                <a:tc>
+                  <a:txBody>
+                    <a:bodyPr/>
+                    <a:lstStyle/>
+                    <a:p>
+                      <a:pPr algn="ctr">
+                        <a:defRPr sz="1600" b="1">
+                          <a:solidFill>
+                            <a:srgbClr val="FFFFFF"/>
+                          </a:solidFill>
+                        </a:defRPr>
+                      </a:pPr>
+                      <a:r>
+                        <a:t>N</a:t>
+                      </a:r>
+                    </a:p>
+                  </a:txBody>
+                  <a:tcPr>
+                    <a:solidFill>
+                      <a:srgbClr val="E74C3C"/>
+                    </a:solidFill>
+                  </a:tcPr>
+                </a:tc>
+                <a:tc>
+                  <a:txBody>
+                    <a:bodyPr/>
+                    <a:lstStyle/>
+                    <a:p>
+                      <a:pPr algn="ctr">
+                        <a:defRPr sz="1600" b="1">
+                          <a:solidFill>
+                            <a:srgbClr val="FFFFFF"/>
+                          </a:solidFill>
+                        </a:defRPr>
+                      </a:pPr>
+                      <a:r>
+                        <a:t>B&amp;B Runtime</a:t>
+                      </a:r>
+                    </a:p>
+                  </a:txBody>
+                  <a:tcPr>
+                    <a:solidFill>
+                      <a:srgbClr val="E74C3C"/>
+                    </a:solidFill>
+                  </a:tcPr>
+                </a:tc>
+                <a:tc>
+                  <a:txBody>
+                    <a:bodyPr/>
+                    <a:lstStyle/>
+                    <a:p>
+                      <a:pPr algn="ctr">
+                        <a:defRPr sz="1600" b="1">
+                          <a:solidFill>
+                            <a:srgbClr val="FFFFFF"/>
+                          </a:solidFill>
+                        </a:defRPr>
+                      </a:pPr>
+                      <a:r>
+                        <a:t>BF Runtime</a:t>
+                      </a:r>
+                    </a:p>
+                  </a:txBody>
+                  <a:tcPr>
+                    <a:solidFill>
+                      <a:srgbClr val="E74C3C"/>
+                    </a:solidFill>
+                  </a:tcPr>
+                </a:tc>
+                <a:tc>
+                  <a:txBody>
+                    <a:bodyPr/>
+                    <a:lstStyle/>
+                    <a:p>
+                      <a:pPr algn="ctr">
+                        <a:defRPr sz="1600" b="1">
+                          <a:solidFill>
+                            <a:srgbClr val="FFFFFF"/>
+                          </a:solidFill>
+                        </a:defRPr>
+                      </a:pPr>
+                      <a:r>
+                        <a:t>B&amp;B Nodes</a:t>
+                      </a:r>
+                    </a:p>
+                  </a:txBody>
+                  <a:tcPr>
+                    <a:solidFill>
+                      <a:srgbClr val="E74C3C"/>
+                    </a:solidFill>
+                  </a:tcPr>
+                </a:tc>
+                <a:tc>
+                  <a:txBody>
+                    <a:bodyPr/>
+                    <a:lstStyle/>
+                    <a:p>
+                      <a:pPr algn="ctr">
+                        <a:defRPr sz="1600" b="1">
+                          <a:solidFill>
+                            <a:srgbClr val="FFFFFF"/>
+                          </a:solidFill>
+                        </a:defRPr>
+                      </a:pPr>
+                      <a:r>
+                        <a:t>BF Nodes</a:t>
+                      </a:r>
+                    </a:p>
+                  </a:txBody>
+                  <a:tcPr>
+                    <a:solidFill>
+                      <a:srgbClr val="E74C3C"/>
+                    </a:solidFill>
+                  </a:tcPr>
+                </a:tc>
+                <a:tc>
+                  <a:txBody>
+                    <a:bodyPr/>
+                    <a:lstStyle/>
+                    <a:p>
+                      <a:pPr algn="ctr">
+                        <a:defRPr sz="1600" b="1">
+                          <a:solidFill>
+                            <a:srgbClr val="FFFFFF"/>
+                          </a:solidFill>
+                        </a:defRPr>
+                      </a:pPr>
+                      <a:r>
+                        <a:t>Pruning Rate</a:t>
+                      </a:r>
+                    </a:p>
+                  </a:txBody>
+                  <a:tcPr>
+                    <a:solidFill>
+                      <a:srgbClr val="E74C3C"/>
+                    </a:solidFill>
+                  </a:tcPr>
+                </a:tc>
+              </a:tr>
+              <a:tr h="640080">
+                <a:tc>
+                  <a:txBody>
+                    <a:bodyPr/>
+                    <a:lstStyle/>
+                    <a:p>
+                      <a:pPr algn="ctr">
+                        <a:defRPr sz="1600">
+                          <a:solidFill>
+                            <a:srgbClr val="2C3E50"/>
+                          </a:solidFill>
+                        </a:defRPr>
+                      </a:pPr>
+                      <a:r>
+                        <a:t>4</a:t>
+                      </a:r>
+                    </a:p>
+                  </a:txBody>
+                  <a:tcPr>
+                    <a:solidFill>
+                      <a:srgbClr val="FFFFFF"/>
+                    </a:solidFill>
+                  </a:tcPr>
+                </a:tc>
+                <a:tc>
+                  <a:txBody>
+                    <a:bodyPr/>
+                    <a:lstStyle/>
+                    <a:p>
+                      <a:pPr algn="ctr">
+                        <a:defRPr sz="1600">
+                          <a:solidFill>
+                            <a:srgbClr val="2C3E50"/>
+                          </a:solidFill>
+                        </a:defRPr>
+                      </a:pPr>
+                      <a:r>
+                        <a:t>0.02ms</a:t>
+                      </a:r>
+                    </a:p>
+                  </a:txBody>
+                  <a:tcPr>
+                    <a:solidFill>
+                      <a:srgbClr val="FFFFFF"/>
+                    </a:solidFill>
+                  </a:tcPr>
+                </a:tc>
+                <a:tc>
+                  <a:txBody>
+                    <a:bodyPr/>
+                    <a:lstStyle/>
+                    <a:p>
+                      <a:pPr algn="ctr">
+                        <a:defRPr sz="1600">
+                          <a:solidFill>
+                            <a:srgbClr val="2C3E50"/>
+                          </a:solidFill>
+                        </a:defRPr>
+                      </a:pPr>
+                      <a:r>
+                        <a:t>0.006ms</a:t>
+                      </a:r>
+                    </a:p>
+                  </a:txBody>
+                  <a:tcPr>
+                    <a:solidFill>
+                      <a:srgbClr val="FFFFFF"/>
+                    </a:solidFill>
+                  </a:tcPr>
+                </a:tc>
+                <a:tc>
+                  <a:txBody>
+                    <a:bodyPr/>
+                    <a:lstStyle/>
+                    <a:p>
+                      <a:pPr algn="ctr">
+                        <a:defRPr sz="1600">
+                          <a:solidFill>
+                            <a:srgbClr val="2C3E50"/>
+                          </a:solidFill>
+                        </a:defRPr>
+                      </a:pPr>
+                      <a:r>
+                        <a:t>15</a:t>
+                      </a:r>
+                    </a:p>
+                  </a:txBody>
+                  <a:tcPr>
+                    <a:solidFill>
+                      <a:srgbClr val="FFFFFF"/>
+                    </a:solidFill>
+                  </a:tcPr>
+                </a:tc>
+                <a:tc>
+                  <a:txBody>
+                    <a:bodyPr/>
+                    <a:lstStyle/>
+                    <a:p>
+                      <a:pPr algn="ctr">
+                        <a:defRPr sz="1600">
+                          <a:solidFill>
+                            <a:srgbClr val="2C3E50"/>
+                          </a:solidFill>
+                        </a:defRPr>
+                      </a:pPr>
+                      <a:r>
+                        <a:t>6</a:t>
+                      </a:r>
+                    </a:p>
+                  </a:txBody>
+                  <a:tcPr>
+                    <a:solidFill>
+                      <a:srgbClr val="FFFFFF"/>
+                    </a:solidFill>
+                  </a:tcPr>
+                </a:tc>
+                <a:tc>
+                  <a:txBody>
+                    <a:bodyPr/>
+                    <a:lstStyle/>
+                    <a:p>
+                      <a:pPr algn="ctr">
+                        <a:defRPr sz="1600">
+                          <a:solidFill>
+                            <a:srgbClr val="2C3E50"/>
+                          </a:solidFill>
+                        </a:defRPr>
+                      </a:pPr>
+                      <a:r>
+                        <a:t>3.8%</a:t>
+                      </a:r>
+                    </a:p>
+                  </a:txBody>
+                  <a:tcPr>
+                    <a:solidFill>
+                      <a:srgbClr val="FFFFFF"/>
+                    </a:solidFill>
+                  </a:tcPr>
+                </a:tc>
+              </a:tr>
+              <a:tr h="640080">
+                <a:tc>
+                  <a:txBody>
+                    <a:bodyPr/>
+                    <a:lstStyle/>
+                    <a:p>
+                      <a:pPr algn="ctr">
+                        <a:defRPr sz="1600">
+                          <a:solidFill>
+                            <a:srgbClr val="2C3E50"/>
+                          </a:solidFill>
+                        </a:defRPr>
+                      </a:pPr>
+                      <a:r>
+                        <a:t>7</a:t>
+                      </a:r>
+                    </a:p>
+                  </a:txBody>
+                  <a:tcPr>
+                    <a:solidFill>
+                      <a:srgbClr val="DFE6E9"/>
+                    </a:solidFill>
+                  </a:tcPr>
+                </a:tc>
+                <a:tc>
+                  <a:txBody>
+                    <a:bodyPr/>
+                    <a:lstStyle/>
+                    <a:p>
+                      <a:pPr algn="ctr">
+                        <a:defRPr sz="1600">
+                          <a:solidFill>
+                            <a:srgbClr val="2C3E50"/>
+                          </a:solidFill>
+                        </a:defRPr>
+                      </a:pPr>
+                      <a:r>
+                        <a:t>0.66ms</a:t>
+                      </a:r>
+                    </a:p>
+                  </a:txBody>
+                  <a:tcPr>
+                    <a:solidFill>
+                      <a:srgbClr val="DFE6E9"/>
+                    </a:solidFill>
+                  </a:tcPr>
+                </a:tc>
+                <a:tc>
+                  <a:txBody>
+                    <a:bodyPr/>
+                    <a:lstStyle/>
+                    <a:p>
+                      <a:pPr algn="ctr">
+                        <a:defRPr sz="1600">
+                          <a:solidFill>
+                            <a:srgbClr val="2C3E50"/>
+                          </a:solidFill>
+                        </a:defRPr>
+                      </a:pPr>
+                      <a:r>
+                        <a:t>0.28ms</a:t>
+                      </a:r>
+                    </a:p>
+                  </a:txBody>
+                  <a:tcPr>
+                    <a:solidFill>
+                      <a:srgbClr val="DFE6E9"/>
+                    </a:solidFill>
+                  </a:tcPr>
+                </a:tc>
+                <a:tc>
+                  <a:txBody>
+                    <a:bodyPr/>
+                    <a:lstStyle/>
+                    <a:p>
+                      <a:pPr algn="ctr">
+                        <a:defRPr sz="1600">
+                          <a:solidFill>
+                            <a:srgbClr val="2C3E50"/>
+                          </a:solidFill>
+                        </a:defRPr>
+                      </a:pPr>
+                      <a:r>
+                        <a:t>428</a:t>
+                      </a:r>
+                    </a:p>
+                  </a:txBody>
+                  <a:tcPr>
+                    <a:solidFill>
+                      <a:srgbClr val="DFE6E9"/>
+                    </a:solidFill>
+                  </a:tcPr>
+                </a:tc>
+                <a:tc>
+                  <a:txBody>
+                    <a:bodyPr/>
+                    <a:lstStyle/>
+                    <a:p>
+                      <a:pPr algn="ctr">
+                        <a:defRPr sz="1600">
+                          <a:solidFill>
+                            <a:srgbClr val="2C3E50"/>
+                          </a:solidFill>
+                        </a:defRPr>
+                      </a:pPr>
+                      <a:r>
+                        <a:t>720</a:t>
+                      </a:r>
+                    </a:p>
+                  </a:txBody>
+                  <a:tcPr>
+                    <a:solidFill>
+                      <a:srgbClr val="DFE6E9"/>
+                    </a:solidFill>
+                  </a:tcPr>
+                </a:tc>
+                <a:tc>
+                  <a:txBody>
+                    <a:bodyPr/>
+                    <a:lstStyle/>
+                    <a:p>
+                      <a:pPr algn="ctr">
+                        <a:defRPr sz="1600">
+                          <a:solidFill>
+                            <a:srgbClr val="2C3E50"/>
+                          </a:solidFill>
+                        </a:defRPr>
+                      </a:pPr>
+                      <a:r>
+                        <a:t>78.1%</a:t>
+                      </a:r>
+                    </a:p>
+                  </a:txBody>
+                  <a:tcPr>
+                    <a:solidFill>
+                      <a:srgbClr val="DFE6E9"/>
+                    </a:solidFill>
+                  </a:tcPr>
+                </a:tc>
+              </a:tr>
+              <a:tr h="640080">
+                <a:tc>
+                  <a:txBody>
+                    <a:bodyPr/>
+                    <a:lstStyle/>
+                    <a:p>
+                      <a:pPr algn="ctr">
+                        <a:defRPr sz="1600">
+                          <a:solidFill>
+                            <a:srgbClr val="2C3E50"/>
+                          </a:solidFill>
+                        </a:defRPr>
+                      </a:pPr>
+                      <a:r>
+                        <a:t>9</a:t>
+                      </a:r>
+                    </a:p>
+                  </a:txBody>
+                  <a:tcPr>
+                    <a:solidFill>
+                      <a:srgbClr val="FFFFFF"/>
+                    </a:solidFill>
+                  </a:tcPr>
+                </a:tc>
+                <a:tc>
+                  <a:txBody>
+                    <a:bodyPr/>
+                    <a:lstStyle/>
+                    <a:p>
+                      <a:pPr algn="ctr">
+                        <a:defRPr sz="1600">
+                          <a:solidFill>
+                            <a:srgbClr val="2C3E50"/>
+                          </a:solidFill>
+                        </a:defRPr>
+                      </a:pPr>
+                      <a:r>
+                        <a:t>6.5ms</a:t>
+                      </a:r>
+                    </a:p>
+                  </a:txBody>
+                  <a:tcPr>
+                    <a:solidFill>
+                      <a:srgbClr val="FFFFFF"/>
+                    </a:solidFill>
+                  </a:tcPr>
+                </a:tc>
+                <a:tc>
+                  <a:txBody>
+                    <a:bodyPr/>
+                    <a:lstStyle/>
+                    <a:p>
+                      <a:pPr algn="ctr">
+                        <a:defRPr sz="1600">
+                          <a:solidFill>
+                            <a:srgbClr val="2C3E50"/>
+                          </a:solidFill>
+                        </a:defRPr>
+                      </a:pPr>
+                      <a:r>
+                        <a:t>14.3ms</a:t>
+                      </a:r>
+                    </a:p>
+                  </a:txBody>
+                  <a:tcPr>
+                    <a:solidFill>
+                      <a:srgbClr val="FFFFFF"/>
+                    </a:solidFill>
+                  </a:tcPr>
+                </a:tc>
+                <a:tc>
+                  <a:txBody>
+                    <a:bodyPr/>
+                    <a:lstStyle/>
+                    <a:p>
+                      <a:pPr algn="ctr">
+                        <a:defRPr sz="1600">
+                          <a:solidFill>
+                            <a:srgbClr val="2C3E50"/>
+                          </a:solidFill>
+                        </a:defRPr>
+                      </a:pPr>
+                      <a:r>
+                        <a:t>4,107</a:t>
+                      </a:r>
+                    </a:p>
+                  </a:txBody>
+                  <a:tcPr>
+                    <a:solidFill>
+                      <a:srgbClr val="FFFFFF"/>
+                    </a:solidFill>
+                  </a:tcPr>
+                </a:tc>
+                <a:tc>
+                  <a:txBody>
+                    <a:bodyPr/>
+                    <a:lstStyle/>
+                    <a:p>
+                      <a:pPr algn="ctr">
+                        <a:defRPr sz="1600">
+                          <a:solidFill>
+                            <a:srgbClr val="2C3E50"/>
+                          </a:solidFill>
+                        </a:defRPr>
+                      </a:pPr>
+                      <a:r>
+                        <a:t>40,320</a:t>
+                      </a:r>
+                    </a:p>
+                  </a:txBody>
+                  <a:tcPr>
+                    <a:solidFill>
+                      <a:srgbClr val="FFFFFF"/>
+                    </a:solidFill>
+                  </a:tcPr>
+                </a:tc>
+                <a:tc>
+                  <a:txBody>
+                    <a:bodyPr/>
+                    <a:lstStyle/>
+                    <a:p>
+                      <a:pPr algn="ctr">
+                        <a:defRPr sz="1600">
+                          <a:solidFill>
+                            <a:srgbClr val="2C3E50"/>
+                          </a:solidFill>
+                        </a:defRPr>
+                      </a:pPr>
+                      <a:r>
+                        <a:t>96.3%</a:t>
+                      </a:r>
+                    </a:p>
+                  </a:txBody>
+                  <a:tcPr>
+                    <a:solidFill>
+                      <a:srgbClr val="FFFFFF"/>
+                    </a:solidFill>
+                  </a:tcPr>
+                </a:tc>
+              </a:tr>
+              <a:tr h="640080">
+                <a:tc>
+                  <a:txBody>
+                    <a:bodyPr/>
+                    <a:lstStyle/>
+                    <a:p>
+                      <a:pPr algn="ctr">
+                        <a:defRPr sz="1600">
+                          <a:solidFill>
+                            <a:srgbClr val="2C3E50"/>
+                          </a:solidFill>
+                        </a:defRPr>
+                      </a:pPr>
+                      <a:r>
+                        <a:t>10</a:t>
+                      </a:r>
+                    </a:p>
+                  </a:txBody>
+                  <a:tcPr>
+                    <a:solidFill>
+                      <a:srgbClr val="DFE6E9"/>
+                    </a:solidFill>
+                  </a:tcPr>
+                </a:tc>
+                <a:tc>
+                  <a:txBody>
+                    <a:bodyPr/>
+                    <a:lstStyle/>
+                    <a:p>
+                      <a:pPr algn="ctr">
+                        <a:defRPr sz="1600">
+                          <a:solidFill>
+                            <a:srgbClr val="2C3E50"/>
+                          </a:solidFill>
+                        </a:defRPr>
+                      </a:pPr>
+                      <a:r>
+                        <a:t>23ms</a:t>
+                      </a:r>
+                    </a:p>
+                  </a:txBody>
+                  <a:tcPr>
+                    <a:solidFill>
+                      <a:srgbClr val="DFE6E9"/>
+                    </a:solidFill>
+                  </a:tcPr>
+                </a:tc>
+                <a:tc>
+                  <a:txBody>
+                    <a:bodyPr/>
+                    <a:lstStyle/>
+                    <a:p>
+                      <a:pPr algn="ctr">
+                        <a:defRPr sz="1600">
+                          <a:solidFill>
+                            <a:srgbClr val="2C3E50"/>
+                          </a:solidFill>
+                        </a:defRPr>
+                      </a:pPr>
+                      <a:r>
+                        <a:t>N/A</a:t>
+                      </a:r>
+                    </a:p>
+                  </a:txBody>
+                  <a:tcPr>
+                    <a:solidFill>
+                      <a:srgbClr val="DFE6E9"/>
+                    </a:solidFill>
+                  </a:tcPr>
+                </a:tc>
+                <a:tc>
+                  <a:txBody>
+                    <a:bodyPr/>
+                    <a:lstStyle/>
+                    <a:p>
+                      <a:pPr algn="ctr">
+                        <a:defRPr sz="1600">
+                          <a:solidFill>
+                            <a:srgbClr val="2C3E50"/>
+                          </a:solidFill>
+                        </a:defRPr>
+                      </a:pPr>
+                      <a:r>
+                        <a:t>12,472</a:t>
+                      </a:r>
+                    </a:p>
+                  </a:txBody>
+                  <a:tcPr>
+                    <a:solidFill>
+                      <a:srgbClr val="DFE6E9"/>
+                    </a:solidFill>
+                  </a:tcPr>
+                </a:tc>
+                <a:tc>
+                  <a:txBody>
+                    <a:bodyPr/>
+                    <a:lstStyle/>
+                    <a:p>
+                      <a:pPr algn="ctr">
+                        <a:defRPr sz="1600">
+                          <a:solidFill>
+                            <a:srgbClr val="2C3E50"/>
+                          </a:solidFill>
+                        </a:defRPr>
+                      </a:pPr>
+                      <a:r>
+                        <a:t>1,814,400</a:t>
+                      </a:r>
+                    </a:p>
+                  </a:txBody>
+                  <a:tcPr>
+                    <a:solidFill>
+                      <a:srgbClr val="DFE6E9"/>
+                    </a:solidFill>
+                  </a:tcPr>
+                </a:tc>
+                <a:tc>
+                  <a:txBody>
+                    <a:bodyPr/>
+                    <a:lstStyle/>
+                    <a:p>
+                      <a:pPr algn="ctr">
+                        <a:defRPr sz="1600">
+                          <a:solidFill>
+                            <a:srgbClr val="2C3E50"/>
+                          </a:solidFill>
+                        </a:defRPr>
+                      </a:pPr>
+                      <a:r>
+                        <a:t>98.7%</a:t>
+                      </a:r>
+                    </a:p>
+                  </a:txBody>
+                  <a:tcPr>
+                    <a:solidFill>
+                      <a:srgbClr val="DFE6E9"/>
+                    </a:solidFill>
+                  </a:tcPr>
+                </a:tc>
+              </a:tr>
+            </a:tbl>
+          </a:graphicData>
+        </a:graphic>
+      </p:graphicFrame>
+      <p:sp>
+        <p:nvSpPr>
+          <p:cNvPr id="4" name="TextBox 3"/>
+          <p:cNvSpPr txBox="1"/>
+          <p:nvPr/>
+        </p:nvSpPr>
+        <p:spPr>
+          <a:xfrm>
+            <a:off x="731520" y="5029200"/>
+            <a:ext cx="10058400" cy="1371600"/>
+          </a:xfrm>
+          <a:prstGeom prst="rect">
+            <a:avLst/>
+          </a:prstGeom>
+          <a:noFill/>
+        </p:spPr>
+        <p:txBody>
+          <a:bodyPr wrap="square">
+            <a:spAutoFit/>
+          </a:bodyPr>
+          <a:lstStyle/>
+          <a:p>
+            <a:pPr algn="l">
+              <a:defRPr sz="1800" b="0">
+                <a:solidFill>
+                  <a:srgbClr val="7F8C8D"/>
+                </a:solidFill>
+              </a:defRPr>
+            </a:pPr>
+            <a:r>
+              <a:t>Key insight: B&amp;B prunes 98.7% of search space at n=10. It becomes faster than BF from n=7 onward. For n=10, BF is infeasible (1.8M paths) while B&amp;B completes in 23ms.</a:t>
+            </a:r>
+          </a:p>
+        </p:txBody>
+      </p:sp>
+    </p:spTree>
+  </p:cSld>
+  <p:clrMapOvr>
+    <a:masterClrMapping/>
+  </p:clrMapOvr>
+</p:sld>
+</file>
+
+<file path=ppt/slides/slide12.xml><?xml version="1.0" encoding="utf-8"?>
+<p:sld xmlns:a="http://schemas.openxmlformats.org/drawingml/2006/main" xmlns:p="http://schemas.openxmlformats.org/presentationml/2006/main" xmlns:r="http://schemas.openxmlformats.org/officeDocument/2006/relationships">
+  <p:cSld>
+    <p:bg>
+      <p:bgPr>
+        <a:solidFill>
+          <a:srgbClr val="2C3E50"/>
+        </a:solidFill>
+        <a:effectLst/>
+      </p:bgPr>
+    </p:bg>
+    <p:spTree>
+      <p:nvGrpSpPr>
+        <p:cNvPr id="1" name=""/>
+        <p:cNvGrpSpPr/>
+        <p:nvPr/>
+      </p:nvGrpSpPr>
+      <p:grpSpPr/>
+      <p:sp>
+        <p:nvSpPr>
+          <p:cNvPr id="2" name="TextBox 1"/>
+          <p:cNvSpPr txBox="1"/>
+          <p:nvPr/>
+        </p:nvSpPr>
+        <p:spPr>
+          <a:xfrm>
+            <a:off x="457200" y="274320"/>
+            <a:ext cx="10972800" cy="914400"/>
+          </a:xfrm>
+          <a:prstGeom prst="rect">
+            <a:avLst/>
+          </a:prstGeom>
+          <a:noFill/>
+        </p:spPr>
+        <p:txBody>
+          <a:bodyPr wrap="square">
+            <a:spAutoFit/>
+          </a:bodyPr>
+          <a:lstStyle/>
+          <a:p>
+            <a:pPr algn="l">
+              <a:defRPr sz="3600" b="1">
+                <a:solidFill>
+                  <a:srgbClr val="E74C3C"/>
+                </a:solidFill>
+              </a:defRPr>
+            </a:pPr>
+            <a:r>
+              <a:t>Summary: Conclusions</a:t>
             </a:r>
           </a:p>
         </p:txBody>
@@ -3458,14 +4272,14 @@
               <a:spcAft>
                 <a:spcPts val="1200"/>
               </a:spcAft>
-              <a:defRPr sz="2200">
+              <a:defRPr sz="2000">
                 <a:solidFill>
                   <a:srgbClr val="FFFFFF"/>
                 </a:solidFill>
               </a:defRPr>
             </a:pPr>
             <a:r>
-              <a:t>Branch and Bound is an effective exact algorithm for small TSP instances.</a:t>
+              <a:t>Branch and Bound is the best choice among these three methods when we need an exact TSP solution but also want better efficiency than simple exhaustive search.</a:t>
             </a:r>
           </a:p>
           <a:p>
@@ -3473,14 +4287,14 @@
               <a:spcAft>
                 <a:spcPts val="1200"/>
               </a:spcAft>
-              <a:defRPr sz="2200">
+              <a:defRPr sz="2000">
                 <a:solidFill>
                   <a:srgbClr val="FFFFFF"/>
                 </a:solidFill>
               </a:defRPr>
             </a:pPr>
             <a:r>
-              <a:t>The minimum-edge-sum lower bound provides substantial pruning even at modest n.</a:t>
+              <a:t>The pruning mechanism becomes more effective as problem size increases — the lower bound provides increasing value for larger instances.</a:t>
             </a:r>
           </a:p>
           <a:p>
@@ -3488,14 +4302,14 @@
               <a:spcAft>
                 <a:spcPts val="1200"/>
               </a:spcAft>
-              <a:defRPr sz="2200">
+              <a:defRPr sz="2000">
                 <a:solidFill>
                   <a:srgbClr val="FFFFFF"/>
                 </a:solidFill>
               </a:defRPr>
             </a:pPr>
             <a:r>
-              <a:t>Future work: Compare with MST-based and Held-Karp lower bounds.</a:t>
+              <a:t>Nearest Neighbor is the fastest but may produce longer routes. Suitable when speed is critical and optimality can be sacrificed.</a:t>
             </a:r>
           </a:p>
           <a:p>
@@ -3503,14 +4317,14 @@
               <a:spcAft>
                 <a:spcPts val="1200"/>
               </a:spcAft>
-              <a:defRPr sz="2200">
+              <a:defRPr sz="2000">
                 <a:solidFill>
                   <a:srgbClr val="FFFFFF"/>
                 </a:solidFill>
               </a:defRPr>
             </a:pPr>
             <a:r>
-              <a:t>Future work: Implement parallel B&amp;B for larger instances.</a:t>
+              <a:t>Brute Force is accurate but does not scale. Its exponential growth makes it unusable beyond 10–12 cities.</a:t>
             </a:r>
           </a:p>
           <a:p>
@@ -3518,14 +4332,14 @@
               <a:spcAft>
                 <a:spcPts val="1200"/>
               </a:spcAft>
-              <a:defRPr sz="2200">
+              <a:defRPr sz="2000">
                 <a:solidFill>
                   <a:srgbClr val="FFFFFF"/>
                 </a:solidFill>
               </a:defRPr>
             </a:pPr>
             <a:r>
-              <a:t>Future work: Hybrid approaches combining B&amp;B with metaheuristics.</a:t>
+              <a:t>Limitation: B&amp;B remains exponential; for n &gt; 20 it becomes impractical. Tighter bounds (MST, Held-Karp) could improve pruning.</a:t>
             </a:r>
           </a:p>
         </p:txBody>
@@ -3538,7 +4352,325 @@
 </p:sld>
 </file>
 
-<file path=ppt/slides/slide12.xml><?xml version="1.0" encoding="utf-8"?>
+<file path=ppt/slides/slide13.xml><?xml version="1.0" encoding="utf-8"?>
+<p:sld xmlns:a="http://schemas.openxmlformats.org/drawingml/2006/main" xmlns:p="http://schemas.openxmlformats.org/presentationml/2006/main" xmlns:r="http://schemas.openxmlformats.org/officeDocument/2006/relationships">
+  <p:cSld>
+    <p:bg>
+      <p:bgPr>
+        <a:solidFill>
+          <a:srgbClr val="2C3E50"/>
+        </a:solidFill>
+        <a:effectLst/>
+      </p:bgPr>
+    </p:bg>
+    <p:spTree>
+      <p:nvGrpSpPr>
+        <p:cNvPr id="1" name=""/>
+        <p:cNvGrpSpPr/>
+        <p:nvPr/>
+      </p:nvGrpSpPr>
+      <p:grpSpPr/>
+      <p:sp>
+        <p:nvSpPr>
+          <p:cNvPr id="2" name="TextBox 1"/>
+          <p:cNvSpPr txBox="1"/>
+          <p:nvPr/>
+        </p:nvSpPr>
+        <p:spPr>
+          <a:xfrm>
+            <a:off x="457200" y="274320"/>
+            <a:ext cx="10972800" cy="914400"/>
+          </a:xfrm>
+          <a:prstGeom prst="rect">
+            <a:avLst/>
+          </a:prstGeom>
+          <a:noFill/>
+        </p:spPr>
+        <p:txBody>
+          <a:bodyPr wrap="square">
+            <a:spAutoFit/>
+          </a:bodyPr>
+          <a:lstStyle/>
+          <a:p>
+            <a:pPr algn="l">
+              <a:defRPr sz="3600" b="1">
+                <a:solidFill>
+                  <a:srgbClr val="E74C3C"/>
+                </a:solidFill>
+              </a:defRPr>
+            </a:pPr>
+            <a:r>
+              <a:t>Key Findings</a:t>
+            </a:r>
+          </a:p>
+        </p:txBody>
+      </p:sp>
+      <p:sp>
+        <p:nvSpPr>
+          <p:cNvPr id="3" name="TextBox 2"/>
+          <p:cNvSpPr txBox="1"/>
+          <p:nvPr/>
+        </p:nvSpPr>
+        <p:spPr>
+          <a:xfrm>
+            <a:off x="457200" y="1371600"/>
+            <a:ext cx="10972800" cy="5029200"/>
+          </a:xfrm>
+          <a:prstGeom prst="rect">
+            <a:avLst/>
+          </a:prstGeom>
+          <a:noFill/>
+        </p:spPr>
+        <p:txBody>
+          <a:bodyPr wrap="square">
+            <a:spAutoFit/>
+          </a:bodyPr>
+          <a:lstStyle/>
+          <a:p>
+            <a:pPr>
+              <a:spcAft>
+                <a:spcPts val="1200"/>
+              </a:spcAft>
+              <a:defRPr sz="2200">
+                <a:solidFill>
+                  <a:srgbClr val="FFFFFF"/>
+                </a:solidFill>
+              </a:defRPr>
+            </a:pPr>
+            <a:r>
+              <a:t>B&amp;B finds provably optimal solutions (same as brute force) for all tested instances.</a:t>
+            </a:r>
+          </a:p>
+          <a:p>
+            <a:pPr>
+              <a:spcAft>
+                <a:spcPts val="1200"/>
+              </a:spcAft>
+              <a:defRPr sz="2200">
+                <a:solidFill>
+                  <a:srgbClr val="FFFFFF"/>
+                </a:solidFill>
+              </a:defRPr>
+            </a:pPr>
+            <a:r>
+              <a:t>At n=10, B&amp;B prunes 98.7% of the search space — visiting only 1.3% of all possible nodes.</a:t>
+            </a:r>
+          </a:p>
+          <a:p>
+            <a:pPr>
+              <a:spcAft>
+                <a:spcPts val="1200"/>
+              </a:spcAft>
+              <a:defRPr sz="2200">
+                <a:solidFill>
+                  <a:srgbClr val="FFFFFF"/>
+                </a:solidFill>
+              </a:defRPr>
+            </a:pPr>
+            <a:r>
+              <a:t>B&amp;B is ~2.2× faster than brute force at n=9; gap widens with larger n.</a:t>
+            </a:r>
+          </a:p>
+          <a:p>
+            <a:pPr>
+              <a:spcAft>
+                <a:spcPts val="1200"/>
+              </a:spcAft>
+              <a:defRPr sz="2200">
+                <a:solidFill>
+                  <a:srgbClr val="FFFFFF"/>
+                </a:solidFill>
+              </a:defRPr>
+            </a:pPr>
+            <a:r>
+              <a:t>Nearest Neighbor runs in near-zero time but solutions are 2-10% above optimal.</a:t>
+            </a:r>
+          </a:p>
+          <a:p>
+            <a:pPr>
+              <a:spcAft>
+                <a:spcPts val="1200"/>
+              </a:spcAft>
+              <a:defRPr sz="2200">
+                <a:solidFill>
+                  <a:srgbClr val="FFFFFF"/>
+                </a:solidFill>
+              </a:defRPr>
+            </a:pPr>
+            <a:r>
+              <a:t>B&amp;B is practical for n ≤ 14; beyond that, heuristics are needed.</a:t>
+            </a:r>
+          </a:p>
+        </p:txBody>
+      </p:sp>
+    </p:spTree>
+  </p:cSld>
+  <p:clrMapOvr>
+    <a:masterClrMapping/>
+  </p:clrMapOvr>
+</p:sld>
+</file>
+
+<file path=ppt/slides/slide14.xml><?xml version="1.0" encoding="utf-8"?>
+<p:sld xmlns:a="http://schemas.openxmlformats.org/drawingml/2006/main" xmlns:p="http://schemas.openxmlformats.org/presentationml/2006/main" xmlns:r="http://schemas.openxmlformats.org/officeDocument/2006/relationships">
+  <p:cSld>
+    <p:bg>
+      <p:bgPr>
+        <a:solidFill>
+          <a:srgbClr val="2C3E50"/>
+        </a:solidFill>
+        <a:effectLst/>
+      </p:bgPr>
+    </p:bg>
+    <p:spTree>
+      <p:nvGrpSpPr>
+        <p:cNvPr id="1" name=""/>
+        <p:cNvGrpSpPr/>
+        <p:nvPr/>
+      </p:nvGrpSpPr>
+      <p:grpSpPr/>
+      <p:sp>
+        <p:nvSpPr>
+          <p:cNvPr id="2" name="TextBox 1"/>
+          <p:cNvSpPr txBox="1"/>
+          <p:nvPr/>
+        </p:nvSpPr>
+        <p:spPr>
+          <a:xfrm>
+            <a:off x="457200" y="274320"/>
+            <a:ext cx="10972800" cy="914400"/>
+          </a:xfrm>
+          <a:prstGeom prst="rect">
+            <a:avLst/>
+          </a:prstGeom>
+          <a:noFill/>
+        </p:spPr>
+        <p:txBody>
+          <a:bodyPr wrap="square">
+            <a:spAutoFit/>
+          </a:bodyPr>
+          <a:lstStyle/>
+          <a:p>
+            <a:pPr algn="l">
+              <a:defRPr sz="3600" b="1">
+                <a:solidFill>
+                  <a:srgbClr val="E74C3C"/>
+                </a:solidFill>
+              </a:defRPr>
+            </a:pPr>
+            <a:r>
+              <a:t>Conclusion &amp; Future Work</a:t>
+            </a:r>
+          </a:p>
+        </p:txBody>
+      </p:sp>
+      <p:sp>
+        <p:nvSpPr>
+          <p:cNvPr id="3" name="TextBox 2"/>
+          <p:cNvSpPr txBox="1"/>
+          <p:nvPr/>
+        </p:nvSpPr>
+        <p:spPr>
+          <a:xfrm>
+            <a:off x="457200" y="1371600"/>
+            <a:ext cx="10972800" cy="5029200"/>
+          </a:xfrm>
+          <a:prstGeom prst="rect">
+            <a:avLst/>
+          </a:prstGeom>
+          <a:noFill/>
+        </p:spPr>
+        <p:txBody>
+          <a:bodyPr wrap="square">
+            <a:spAutoFit/>
+          </a:bodyPr>
+          <a:lstStyle/>
+          <a:p>
+            <a:pPr>
+              <a:spcAft>
+                <a:spcPts val="1200"/>
+              </a:spcAft>
+              <a:defRPr sz="2200">
+                <a:solidFill>
+                  <a:srgbClr val="FFFFFF"/>
+                </a:solidFill>
+              </a:defRPr>
+            </a:pPr>
+            <a:r>
+              <a:t>Branch and Bound is an effective exact algorithm for small TSP instances.</a:t>
+            </a:r>
+          </a:p>
+          <a:p>
+            <a:pPr>
+              <a:spcAft>
+                <a:spcPts val="1200"/>
+              </a:spcAft>
+              <a:defRPr sz="2200">
+                <a:solidFill>
+                  <a:srgbClr val="FFFFFF"/>
+                </a:solidFill>
+              </a:defRPr>
+            </a:pPr>
+            <a:r>
+              <a:t>The minimum-edge-sum lower bound provides substantial pruning even at modest n.</a:t>
+            </a:r>
+          </a:p>
+          <a:p>
+            <a:pPr>
+              <a:spcAft>
+                <a:spcPts val="1200"/>
+              </a:spcAft>
+              <a:defRPr sz="2200">
+                <a:solidFill>
+                  <a:srgbClr val="FFFFFF"/>
+                </a:solidFill>
+              </a:defRPr>
+            </a:pPr>
+            <a:r>
+              <a:t>Future work: Compare with MST-based and Held-Karp lower bounds.</a:t>
+            </a:r>
+          </a:p>
+          <a:p>
+            <a:pPr>
+              <a:spcAft>
+                <a:spcPts val="1200"/>
+              </a:spcAft>
+              <a:defRPr sz="2200">
+                <a:solidFill>
+                  <a:srgbClr val="FFFFFF"/>
+                </a:solidFill>
+              </a:defRPr>
+            </a:pPr>
+            <a:r>
+              <a:t>Future work: Implement parallel B&amp;B for larger instances.</a:t>
+            </a:r>
+          </a:p>
+          <a:p>
+            <a:pPr>
+              <a:spcAft>
+                <a:spcPts val="1200"/>
+              </a:spcAft>
+              <a:defRPr sz="2200">
+                <a:solidFill>
+                  <a:srgbClr val="FFFFFF"/>
+                </a:solidFill>
+              </a:defRPr>
+            </a:pPr>
+            <a:r>
+              <a:t>Future work: Hybrid approaches combining B&amp;B with metaheuristics.</a:t>
+            </a:r>
+          </a:p>
+        </p:txBody>
+      </p:sp>
+    </p:spTree>
+  </p:cSld>
+  <p:clrMapOvr>
+    <a:masterClrMapping/>
+  </p:clrMapOvr>
+</p:sld>
+</file>
+
+<file path=ppt/slides/slide15.xml><?xml version="1.0" encoding="utf-8"?>
 <p:sld xmlns:a="http://schemas.openxmlformats.org/drawingml/2006/main" xmlns:p="http://schemas.openxmlformats.org/presentationml/2006/main" xmlns:r="http://schemas.openxmlformats.org/officeDocument/2006/relationships">
   <p:cSld>
     <p:bg>

</xml_diff>